<commit_message>
submit: unify test count 128 in 01/02; 04 safety report v1
</commit_message>
<xml_diff>
--- a/submit/02_答辩材料_v1.pptx
+++ b/submit/02_答辩材料_v1.pptx
@@ -1607,6 +1607,10 @@
           </a:solidFill>
           <a:ln/>
         </p:spPr>
+        <p:txBody>
+          <a:bodyPr/>
+          <a:p/>
+        </p:txBody>
       </p:sp>
       <p:sp>
         <p:nvSpPr>
@@ -2137,6 +2141,10 @@
             <a:prstDash val="solid"/>
           </a:ln>
         </p:spPr>
+        <p:txBody>
+          <a:bodyPr/>
+          <a:p/>
+        </p:txBody>
       </p:sp>
       <p:sp>
         <p:nvSpPr>
@@ -2157,6 +2165,10 @@
           </a:solidFill>
           <a:ln/>
         </p:spPr>
+        <p:txBody>
+          <a:bodyPr/>
+          <a:p/>
+        </p:txBody>
       </p:sp>
       <p:sp>
         <p:nvSpPr>
@@ -2279,6 +2291,10 @@
             <a:prstDash val="solid"/>
           </a:ln>
         </p:spPr>
+        <p:txBody>
+          <a:bodyPr/>
+          <a:p/>
+        </p:txBody>
       </p:sp>
       <p:sp>
         <p:nvSpPr>
@@ -2299,6 +2315,10 @@
           </a:solidFill>
           <a:ln/>
         </p:spPr>
+        <p:txBody>
+          <a:bodyPr/>
+          <a:p/>
+        </p:txBody>
       </p:sp>
       <p:sp>
         <p:nvSpPr>
@@ -2421,6 +2441,10 @@
             <a:prstDash val="solid"/>
           </a:ln>
         </p:spPr>
+        <p:txBody>
+          <a:bodyPr/>
+          <a:p/>
+        </p:txBody>
       </p:sp>
       <p:sp>
         <p:nvSpPr>
@@ -2441,6 +2465,10 @@
           </a:solidFill>
           <a:ln/>
         </p:spPr>
+        <p:txBody>
+          <a:bodyPr/>
+          <a:p/>
+        </p:txBody>
       </p:sp>
       <p:sp>
         <p:nvSpPr>
@@ -2563,6 +2591,10 @@
             <a:prstDash val="solid"/>
           </a:ln>
         </p:spPr>
+        <p:txBody>
+          <a:bodyPr/>
+          <a:p/>
+        </p:txBody>
       </p:sp>
       <p:sp>
         <p:nvSpPr>
@@ -2583,6 +2615,10 @@
           </a:solidFill>
           <a:ln/>
         </p:spPr>
+        <p:txBody>
+          <a:bodyPr/>
+          <a:p/>
+        </p:txBody>
       </p:sp>
       <p:sp>
         <p:nvSpPr>
@@ -2932,6 +2968,10 @@
             <a:prstDash val="solid"/>
           </a:ln>
         </p:spPr>
+        <p:txBody>
+          <a:bodyPr/>
+          <a:p/>
+        </p:txBody>
       </p:sp>
       <p:sp>
         <p:nvSpPr>
@@ -3132,6 +3172,10 @@
             <a:prstDash val="solid"/>
           </a:ln>
         </p:spPr>
+        <p:txBody>
+          <a:bodyPr/>
+          <a:p/>
+        </p:txBody>
       </p:sp>
       <p:sp>
         <p:nvSpPr>
@@ -3332,6 +3376,10 @@
             <a:prstDash val="solid"/>
           </a:ln>
         </p:spPr>
+        <p:txBody>
+          <a:bodyPr/>
+          <a:p/>
+        </p:txBody>
       </p:sp>
       <p:sp>
         <p:nvSpPr>
@@ -3532,6 +3580,10 @@
             <a:prstDash val="solid"/>
           </a:ln>
         </p:spPr>
+        <p:txBody>
+          <a:bodyPr/>
+          <a:p/>
+        </p:txBody>
       </p:sp>
       <p:sp>
         <p:nvSpPr>
@@ -3693,6 +3745,10 @@
             <a:prstDash val="solid"/>
           </a:ln>
         </p:spPr>
+        <p:txBody>
+          <a:bodyPr/>
+          <a:p/>
+        </p:txBody>
       </p:sp>
       <p:sp>
         <p:nvSpPr>
@@ -4029,6 +4085,10 @@
             <a:prstDash val="solid"/>
           </a:ln>
         </p:spPr>
+        <p:txBody>
+          <a:bodyPr/>
+          <a:p/>
+        </p:txBody>
       </p:sp>
       <p:sp>
         <p:nvSpPr>
@@ -4173,6 +4233,10 @@
             <a:prstDash val="solid"/>
           </a:ln>
         </p:spPr>
+        <p:txBody>
+          <a:bodyPr/>
+          <a:p/>
+        </p:txBody>
       </p:sp>
       <p:sp>
         <p:nvSpPr>
@@ -4317,6 +4381,10 @@
             <a:prstDash val="solid"/>
           </a:ln>
         </p:spPr>
+        <p:txBody>
+          <a:bodyPr/>
+          <a:p/>
+        </p:txBody>
       </p:sp>
       <p:sp>
         <p:nvSpPr>
@@ -4461,6 +4529,10 @@
             <a:prstDash val="solid"/>
           </a:ln>
         </p:spPr>
+        <p:txBody>
+          <a:bodyPr/>
+          <a:p/>
+        </p:txBody>
       </p:sp>
       <p:sp>
         <p:nvSpPr>
@@ -4605,6 +4677,10 @@
             <a:prstDash val="solid"/>
           </a:ln>
         </p:spPr>
+        <p:txBody>
+          <a:bodyPr/>
+          <a:p/>
+        </p:txBody>
       </p:sp>
       <p:sp>
         <p:nvSpPr>
@@ -4710,6 +4786,10 @@
             <a:prstDash val="solid"/>
           </a:ln>
         </p:spPr>
+        <p:txBody>
+          <a:bodyPr/>
+          <a:p/>
+        </p:txBody>
       </p:sp>
       <p:sp>
         <p:nvSpPr>
@@ -4815,6 +4895,10 @@
             <a:prstDash val="solid"/>
           </a:ln>
         </p:spPr>
+        <p:txBody>
+          <a:bodyPr/>
+          <a:p/>
+        </p:txBody>
       </p:sp>
       <p:sp>
         <p:nvSpPr>
@@ -4920,6 +5004,10 @@
             <a:prstDash val="solid"/>
           </a:ln>
         </p:spPr>
+        <p:txBody>
+          <a:bodyPr/>
+          <a:p/>
+        </p:txBody>
       </p:sp>
       <p:sp>
         <p:nvSpPr>
@@ -5025,6 +5113,10 @@
             <a:prstDash val="solid"/>
           </a:ln>
         </p:spPr>
+        <p:txBody>
+          <a:bodyPr/>
+          <a:p/>
+        </p:txBody>
       </p:sp>
       <p:sp>
         <p:nvSpPr>
@@ -5130,6 +5222,10 @@
             <a:prstDash val="solid"/>
           </a:ln>
         </p:spPr>
+        <p:txBody>
+          <a:bodyPr/>
+          <a:p/>
+        </p:txBody>
       </p:sp>
       <p:sp>
         <p:nvSpPr>
@@ -5203,7 +5299,7 @@
                 <a:ea typeface="Noto Sans CJK SC" pitchFamily="34" charset="-122"/>
                 <a:cs typeface="Noto Sans CJK SC" pitchFamily="34" charset="-120"/>
               </a:rPr>
-              <a:t>83 passed（pytest）</a:t>
+              <a:t>128 passed（pytest）</a:t>
             </a:r>
             <a:endParaRPr lang="en-US" sz="1300" dirty="0"/>
           </a:p>
@@ -5235,6 +5331,10 @@
             <a:prstDash val="solid"/>
           </a:ln>
         </p:spPr>
+        <p:txBody>
+          <a:bodyPr/>
+          <a:p/>
+        </p:txBody>
       </p:sp>
       <p:sp>
         <p:nvSpPr>
@@ -5528,6 +5628,10 @@
             <a:prstDash val="solid"/>
           </a:ln>
         </p:spPr>
+        <p:txBody>
+          <a:bodyPr/>
+          <a:p/>
+        </p:txBody>
       </p:sp>
       <p:sp>
         <p:nvSpPr>
@@ -5548,6 +5652,10 @@
           </a:solidFill>
           <a:ln/>
         </p:spPr>
+        <p:txBody>
+          <a:bodyPr/>
+          <a:p/>
+        </p:txBody>
       </p:sp>
       <p:sp>
         <p:nvSpPr>
@@ -5809,6 +5917,10 @@
             <a:prstDash val="solid"/>
           </a:ln>
         </p:spPr>
+        <p:txBody>
+          <a:bodyPr/>
+          <a:p/>
+        </p:txBody>
       </p:sp>
       <p:sp>
         <p:nvSpPr>
@@ -5829,6 +5941,10 @@
           </a:solidFill>
           <a:ln/>
         </p:spPr>
+        <p:txBody>
+          <a:bodyPr/>
+          <a:p/>
+        </p:txBody>
       </p:sp>
       <p:sp>
         <p:nvSpPr>
@@ -6090,6 +6206,10 @@
             <a:prstDash val="solid"/>
           </a:ln>
         </p:spPr>
+        <p:txBody>
+          <a:bodyPr/>
+          <a:p/>
+        </p:txBody>
       </p:sp>
       <p:sp>
         <p:nvSpPr>
@@ -6110,6 +6230,10 @@
           </a:solidFill>
           <a:ln/>
         </p:spPr>
+        <p:txBody>
+          <a:bodyPr/>
+          <a:p/>
+        </p:txBody>
       </p:sp>
       <p:sp>
         <p:nvSpPr>
@@ -7605,6 +7729,10 @@
             <a:prstDash val="solid"/>
           </a:ln>
         </p:spPr>
+        <p:txBody>
+          <a:bodyPr/>
+          <a:p/>
+        </p:txBody>
       </p:sp>
       <p:sp>
         <p:nvSpPr>
@@ -7749,6 +7877,10 @@
             <a:prstDash val="solid"/>
           </a:ln>
         </p:spPr>
+        <p:txBody>
+          <a:bodyPr/>
+          <a:p/>
+        </p:txBody>
       </p:sp>
       <p:sp>
         <p:nvSpPr>
@@ -7893,6 +8025,10 @@
             <a:prstDash val="solid"/>
           </a:ln>
         </p:spPr>
+        <p:txBody>
+          <a:bodyPr/>
+          <a:p/>
+        </p:txBody>
       </p:sp>
       <p:sp>
         <p:nvSpPr>
@@ -8037,6 +8173,10 @@
             <a:prstDash val="solid"/>
           </a:ln>
         </p:spPr>
+        <p:txBody>
+          <a:bodyPr/>
+          <a:p/>
+        </p:txBody>
       </p:sp>
       <p:sp>
         <p:nvSpPr>
@@ -8181,6 +8321,10 @@
             <a:prstDash val="solid"/>
           </a:ln>
         </p:spPr>
+        <p:txBody>
+          <a:bodyPr/>
+          <a:p/>
+        </p:txBody>
       </p:sp>
       <p:sp>
         <p:nvSpPr>
@@ -8271,7 +8415,7 @@
                 <a:ea typeface="Noto Sans CJK SC" pitchFamily="34" charset="-122"/>
                 <a:cs typeface="Noto Sans CJK SC" pitchFamily="34" charset="-120"/>
               </a:rPr>
-              <a:t>单测当前 83 passed  ·  对抗集 103 条真跑  ·  指标口径【待依灵确认】前不对外签章引用</a:t>
+              <a:t>单测当前 128 passed  ·  对抗集 103 条真跑  ·  指标口径【待依灵确认】前不对外签章引用</a:t>
             </a:r>
             <a:endParaRPr lang="en-US" sz="1400" dirty="0"/>
           </a:p>
@@ -8569,6 +8713,10 @@
             <a:prstDash val="solid"/>
           </a:ln>
         </p:spPr>
+        <p:txBody>
+          <a:bodyPr/>
+          <a:p/>
+        </p:txBody>
       </p:sp>
       <p:sp>
         <p:nvSpPr>
@@ -8674,6 +8822,10 @@
             <a:prstDash val="solid"/>
           </a:ln>
         </p:spPr>
+        <p:txBody>
+          <a:bodyPr/>
+          <a:p/>
+        </p:txBody>
       </p:sp>
       <p:sp>
         <p:nvSpPr>
@@ -8779,6 +8931,10 @@
             <a:prstDash val="solid"/>
           </a:ln>
         </p:spPr>
+        <p:txBody>
+          <a:bodyPr/>
+          <a:p/>
+        </p:txBody>
       </p:sp>
       <p:sp>
         <p:nvSpPr>
@@ -8884,6 +9040,10 @@
             <a:prstDash val="solid"/>
           </a:ln>
         </p:spPr>
+        <p:txBody>
+          <a:bodyPr/>
+          <a:p/>
+        </p:txBody>
       </p:sp>
       <p:sp>
         <p:nvSpPr>
@@ -8989,6 +9149,10 @@
             <a:prstDash val="solid"/>
           </a:ln>
         </p:spPr>
+        <p:txBody>
+          <a:bodyPr/>
+          <a:p/>
+        </p:txBody>
       </p:sp>
       <p:sp>
         <p:nvSpPr>
@@ -9094,6 +9258,10 @@
             <a:prstDash val="solid"/>
           </a:ln>
         </p:spPr>
+        <p:txBody>
+          <a:bodyPr/>
+          <a:p/>
+        </p:txBody>
       </p:sp>
       <p:sp>
         <p:nvSpPr>
@@ -9199,6 +9367,10 @@
             <a:prstDash val="solid"/>
           </a:ln>
         </p:spPr>
+        <p:txBody>
+          <a:bodyPr/>
+          <a:p/>
+        </p:txBody>
       </p:sp>
       <p:sp>
         <p:nvSpPr>
@@ -9304,6 +9476,10 @@
             <a:prstDash val="solid"/>
           </a:ln>
         </p:spPr>
+        <p:txBody>
+          <a:bodyPr/>
+          <a:p/>
+        </p:txBody>
       </p:sp>
       <p:sp>
         <p:nvSpPr>
@@ -9512,6 +9688,10 @@
           </a:solidFill>
           <a:ln/>
         </p:spPr>
+        <p:txBody>
+          <a:bodyPr/>
+          <a:p/>
+        </p:txBody>
       </p:sp>
       <p:sp>
         <p:nvSpPr>
@@ -9690,6 +9870,10 @@
             <a:prstDash val="solid"/>
           </a:ln>
         </p:spPr>
+        <p:txBody>
+          <a:bodyPr/>
+          <a:p/>
+        </p:txBody>
       </p:sp>
       <p:sp>
         <p:nvSpPr>

</xml_diff>